<commit_message>
Update HPO Stream Package Builder - Master Template.pptx
</commit_message>
<xml_diff>
--- a/Assets/HPO Stream Package Builder - Master Template.pptx
+++ b/Assets/HPO Stream Package Builder - Master Template.pptx
@@ -7831,7 +7831,7 @@
                 </a:solidFill>
                 <a:latin typeface="Spectrum Sans Bold" panose="02110004020202020204"/>
               </a:rPr>
-              <a:t>XXX DMA</a:t>
+              <a:t>HPO Live In-Telecast Package:</a:t>
             </a:r>
           </a:p>
         </p:txBody>
@@ -8414,6 +8414,47 @@
               </a:rPr>
               <a:t>[Client Name]</a:t>
             </a:r>
+          </a:p>
+        </p:txBody>
+      </p:sp>
+      <p:sp>
+        <p:nvSpPr>
+          <p:cNvPr id="7" name="TextBox 6">
+            <a:extLst>
+              <a:ext uri="{FF2B5EF4-FFF2-40B4-BE49-F238E27FC236}">
+                <a16:creationId xmlns:a16="http://schemas.microsoft.com/office/drawing/2014/main" id="{E46F3FA4-506B-4B36-60A1-FFDEAD85AC66}"/>
+              </a:ext>
+            </a:extLst>
+          </p:cNvPr>
+          <p:cNvSpPr txBox="1"/>
+          <p:nvPr/>
+        </p:nvSpPr>
+        <p:spPr>
+          <a:xfrm>
+            <a:off x="5480191" y="2575507"/>
+            <a:ext cx="6206986" cy="307777"/>
+          </a:xfrm>
+          <a:prstGeom prst="rect">
+            <a:avLst/>
+          </a:prstGeom>
+          <a:noFill/>
+        </p:spPr>
+        <p:txBody>
+          <a:bodyPr wrap="square">
+            <a:spAutoFit/>
+          </a:bodyPr>
+          <a:lstStyle/>
+          <a:p>
+            <a:r>
+              <a:rPr lang="en-US" sz="1400" b="1" dirty="0">
+                <a:solidFill>
+                  <a:srgbClr val="D5D5D5"/>
+                </a:solidFill>
+                <a:latin typeface="Spectrum Sans Bold" panose="02110004020202020204"/>
+              </a:rPr>
+              <a:t>XXX DMA</a:t>
+            </a:r>
+            <a:endParaRPr lang="en-US" sz="1400" dirty="0"/>
           </a:p>
         </p:txBody>
       </p:sp>
@@ -10429,8 +10470,36 @@
 </file>
 
 <file path=customXml/item1.xml><?xml version="1.0" encoding="utf-8"?>
-<?mso-contentType ?>
-<FormTemplates xmlns="http://schemas.microsoft.com/sharepoint/v3/contenttype/forms"/>
+<p:properties xmlns:p="http://schemas.microsoft.com/office/2006/metadata/properties" xmlns:xsi="http://www.w3.org/2001/XMLSchema-instance" xmlns:pc="http://schemas.microsoft.com/office/infopath/2007/PartnerControls">
+  <documentManagement>
+    <TaxCatchAll xmlns="a0547eee-aaa8-4b90-a1b8-3c540830c94d" xsi:nil="true"/>
+    <j54b65ba43ff43c48723fc8adc29d268 xmlns="a0547eee-aaa8-4b90-a1b8-3c540830c94d">
+      <Terms xmlns="http://schemas.microsoft.com/office/infopath/2007/PartnerControls"/>
+    </j54b65ba43ff43c48723fc8adc29d268>
+    <l420c45215364e2eb38c14ab041199ab xmlns="a0547eee-aaa8-4b90-a1b8-3c540830c94d">
+      <Terms xmlns="http://schemas.microsoft.com/office/infopath/2007/PartnerControls"/>
+    </l420c45215364e2eb38c14ab041199ab>
+    <la4ae81035174b1fba751a07ca4d086b xmlns="a0547eee-aaa8-4b90-a1b8-3c540830c94d">
+      <Terms xmlns="http://schemas.microsoft.com/office/infopath/2007/PartnerControls"/>
+    </la4ae81035174b1fba751a07ca4d086b>
+    <_dlc_DocIdPersistId xmlns="a0547eee-aaa8-4b90-a1b8-3c540830c94d" xsi:nil="true"/>
+    <SROwner xmlns="a0547eee-aaa8-4b90-a1b8-3c540830c94d">
+      <UserInfo>
+        <DisplayName/>
+        <AccountId xsi:nil="true"/>
+        <AccountType/>
+      </UserInfo>
+    </SROwner>
+    <SRRenewal xmlns="a0547eee-aaa8-4b90-a1b8-3c540830c94d" xsi:nil="true"/>
+    <j7c24873d3bf4df793fceec9ac332839 xmlns="a0547eee-aaa8-4b90-a1b8-3c540830c94d">
+      <Terms xmlns="http://schemas.microsoft.com/office/infopath/2007/PartnerControls"/>
+    </j7c24873d3bf4df793fceec9ac332839>
+    <SRThumbnail xmlns="a0547eee-aaa8-4b90-a1b8-3c540830c94d">
+      <Url xsi:nil="true"/>
+      <Description xsi:nil="true"/>
+    </SRThumbnail>
+  </documentManagement>
+</p:properties>
 </file>
 
 <file path=customXml/item2.xml><?xml version="1.0" encoding="utf-8"?>
@@ -10705,36 +10774,8 @@
 </file>
 
 <file path=customXml/item3.xml><?xml version="1.0" encoding="utf-8"?>
-<p:properties xmlns:p="http://schemas.microsoft.com/office/2006/metadata/properties" xmlns:xsi="http://www.w3.org/2001/XMLSchema-instance" xmlns:pc="http://schemas.microsoft.com/office/infopath/2007/PartnerControls">
-  <documentManagement>
-    <TaxCatchAll xmlns="a0547eee-aaa8-4b90-a1b8-3c540830c94d" xsi:nil="true"/>
-    <j54b65ba43ff43c48723fc8adc29d268 xmlns="a0547eee-aaa8-4b90-a1b8-3c540830c94d">
-      <Terms xmlns="http://schemas.microsoft.com/office/infopath/2007/PartnerControls"/>
-    </j54b65ba43ff43c48723fc8adc29d268>
-    <l420c45215364e2eb38c14ab041199ab xmlns="a0547eee-aaa8-4b90-a1b8-3c540830c94d">
-      <Terms xmlns="http://schemas.microsoft.com/office/infopath/2007/PartnerControls"/>
-    </l420c45215364e2eb38c14ab041199ab>
-    <la4ae81035174b1fba751a07ca4d086b xmlns="a0547eee-aaa8-4b90-a1b8-3c540830c94d">
-      <Terms xmlns="http://schemas.microsoft.com/office/infopath/2007/PartnerControls"/>
-    </la4ae81035174b1fba751a07ca4d086b>
-    <_dlc_DocIdPersistId xmlns="a0547eee-aaa8-4b90-a1b8-3c540830c94d" xsi:nil="true"/>
-    <SROwner xmlns="a0547eee-aaa8-4b90-a1b8-3c540830c94d">
-      <UserInfo>
-        <DisplayName/>
-        <AccountId xsi:nil="true"/>
-        <AccountType/>
-      </UserInfo>
-    </SROwner>
-    <SRRenewal xmlns="a0547eee-aaa8-4b90-a1b8-3c540830c94d" xsi:nil="true"/>
-    <j7c24873d3bf4df793fceec9ac332839 xmlns="a0547eee-aaa8-4b90-a1b8-3c540830c94d">
-      <Terms xmlns="http://schemas.microsoft.com/office/infopath/2007/PartnerControls"/>
-    </j7c24873d3bf4df793fceec9ac332839>
-    <SRThumbnail xmlns="a0547eee-aaa8-4b90-a1b8-3c540830c94d">
-      <Url xsi:nil="true"/>
-      <Description xsi:nil="true"/>
-    </SRThumbnail>
-  </documentManagement>
-</p:properties>
+<?mso-contentType ?>
+<FormTemplates xmlns="http://schemas.microsoft.com/sharepoint/v3/contenttype/forms"/>
 </file>
 
 <file path=customXml/item4.xml><?xml version="1.0" encoding="utf-8"?>
@@ -10743,9 +10784,19 @@
 </file>
 
 <file path=customXml/itemProps1.xml><?xml version="1.0" encoding="utf-8"?>
-<ds:datastoreItem xmlns:ds="http://schemas.openxmlformats.org/officeDocument/2006/customXml" ds:itemID="{EC52D6D2-615C-42E8-A3C5-D765C3285355}">
+<ds:datastoreItem xmlns:ds="http://schemas.openxmlformats.org/officeDocument/2006/customXml" ds:itemID="{A4A687C3-2BAD-4AD7-9EA3-756AF9ACB115}">
   <ds:schemaRefs>
-    <ds:schemaRef ds:uri="http://schemas.microsoft.com/sharepoint/v3/contenttype/forms"/>
+    <ds:schemaRef ds:uri="http://schemas.microsoft.com/office/2006/metadata/properties"/>
+    <ds:schemaRef ds:uri="http://schemas.microsoft.com/office/infopath/2007/PartnerControls"/>
+    <ds:schemaRef ds:uri="http://www.w3.org/XML/1998/namespace"/>
+    <ds:schemaRef ds:uri="http://schemas.microsoft.com/office/2006/documentManagement/types"/>
+    <ds:schemaRef ds:uri="http://purl.org/dc/elements/1.1/"/>
+    <ds:schemaRef ds:uri="http://purl.org/dc/terms/"/>
+    <ds:schemaRef ds:uri="0212352b-2682-46bb-beb5-9da4ea9226e1"/>
+    <ds:schemaRef ds:uri="7a70ef4c-5183-4fb2-bf69-1cc1bbd63d67"/>
+    <ds:schemaRef ds:uri="http://schemas.openxmlformats.org/package/2006/metadata/core-properties"/>
+    <ds:schemaRef ds:uri="http://purl.org/dc/dcmitype/"/>
+    <ds:schemaRef ds:uri="a0547eee-aaa8-4b90-a1b8-3c540830c94d"/>
   </ds:schemaRefs>
 </ds:datastoreItem>
 </file>
@@ -10770,19 +10821,9 @@
 </file>
 
 <file path=customXml/itemProps3.xml><?xml version="1.0" encoding="utf-8"?>
-<ds:datastoreItem xmlns:ds="http://schemas.openxmlformats.org/officeDocument/2006/customXml" ds:itemID="{A4A687C3-2BAD-4AD7-9EA3-756AF9ACB115}">
+<ds:datastoreItem xmlns:ds="http://schemas.openxmlformats.org/officeDocument/2006/customXml" ds:itemID="{EC52D6D2-615C-42E8-A3C5-D765C3285355}">
   <ds:schemaRefs>
-    <ds:schemaRef ds:uri="http://schemas.microsoft.com/office/2006/metadata/properties"/>
-    <ds:schemaRef ds:uri="http://schemas.microsoft.com/office/infopath/2007/PartnerControls"/>
-    <ds:schemaRef ds:uri="http://www.w3.org/XML/1998/namespace"/>
-    <ds:schemaRef ds:uri="http://schemas.microsoft.com/office/2006/documentManagement/types"/>
-    <ds:schemaRef ds:uri="http://purl.org/dc/elements/1.1/"/>
-    <ds:schemaRef ds:uri="http://purl.org/dc/terms/"/>
-    <ds:schemaRef ds:uri="0212352b-2682-46bb-beb5-9da4ea9226e1"/>
-    <ds:schemaRef ds:uri="7a70ef4c-5183-4fb2-bf69-1cc1bbd63d67"/>
-    <ds:schemaRef ds:uri="http://schemas.openxmlformats.org/package/2006/metadata/core-properties"/>
-    <ds:schemaRef ds:uri="http://purl.org/dc/dcmitype/"/>
-    <ds:schemaRef ds:uri="a0547eee-aaa8-4b90-a1b8-3c540830c94d"/>
+    <ds:schemaRef ds:uri="http://schemas.microsoft.com/sharepoint/v3/contenttype/forms"/>
   </ds:schemaRefs>
 </ds:datastoreItem>
 </file>

</xml_diff>

<commit_message>
Update to write custom rates and hpos
</commit_message>
<xml_diff>
--- a/Assets/HPO Stream Package Builder - Master Template.pptx
+++ b/Assets/HPO Stream Package Builder - Master Template.pptx
@@ -229,7 +229,7 @@
           <a:p>
             <a:fld id="{D28EEBFE-8A87-DC4B-83D1-64E9257E4E50}" type="datetimeFigureOut">
               <a:rPr lang="en-US" smtClean="0"/>
-              <a:t>3/24/2026</a:t>
+              <a:t>3/31/2026</a:t>
             </a:fld>
             <a:endParaRPr lang="en-US" dirty="0"/>
           </a:p>
@@ -406,7 +406,7 @@
           <a:p>
             <a:fld id="{1D6A9494-7432-4242-91E8-82B2FB80EE9E}" type="datetimeFigureOut">
               <a:rPr lang="en-US" smtClean="0"/>
-              <a:t>3/24/2026</a:t>
+              <a:t>3/31/2026</a:t>
             </a:fld>
             <a:endParaRPr lang="en-US" dirty="0"/>
           </a:p>
@@ -802,7 +802,7 @@
           <a:p>
             <a:fld id="{490F82D5-E79D-AA43-A25E-D6C391467F8C}" type="datetime1">
               <a:rPr lang="en-CA" smtClean="0"/>
-              <a:t>2026-03-24</a:t>
+              <a:t>2026-03-31</a:t>
             </a:fld>
             <a:endParaRPr lang="en-US" dirty="0"/>
           </a:p>
@@ -2393,7 +2393,7 @@
           <a:p>
             <a:fld id="{490F82D5-E79D-AA43-A25E-D6C391467F8C}" type="datetime1">
               <a:rPr lang="en-CA" smtClean="0"/>
-              <a:t>2026-03-24</a:t>
+              <a:t>2026-03-31</a:t>
             </a:fld>
             <a:endParaRPr lang="en-US" dirty="0"/>
           </a:p>
@@ -4125,7 +4125,7 @@
           <a:p>
             <a:fld id="{684576CA-1569-584A-A50E-3CEA5FEA6A2C}" type="datetime1">
               <a:rPr lang="en-CA" smtClean="0"/>
-              <a:t>2026-03-24</a:t>
+              <a:t>2026-03-31</a:t>
             </a:fld>
             <a:endParaRPr lang="en-US" dirty="0"/>
           </a:p>
@@ -4794,7 +4794,7 @@
           <a:p>
             <a:fld id="{684576CA-1569-584A-A50E-3CEA5FEA6A2C}" type="datetime1">
               <a:rPr lang="en-CA" smtClean="0"/>
-              <a:t>2026-03-24</a:t>
+              <a:t>2026-03-31</a:t>
             </a:fld>
             <a:endParaRPr lang="en-US"/>
           </a:p>
@@ -5467,7 +5467,7 @@
           <a:p>
             <a:fld id="{684576CA-1569-584A-A50E-3CEA5FEA6A2C}" type="datetime1">
               <a:rPr lang="en-CA" smtClean="0"/>
-              <a:t>2026-03-24</a:t>
+              <a:t>2026-03-31</a:t>
             </a:fld>
             <a:endParaRPr lang="en-US" dirty="0"/>
           </a:p>
@@ -6136,7 +6136,7 @@
           <a:p>
             <a:fld id="{684576CA-1569-584A-A50E-3CEA5FEA6A2C}" type="datetime1">
               <a:rPr lang="en-CA" smtClean="0"/>
-              <a:t>2026-03-24</a:t>
+              <a:t>2026-03-31</a:t>
             </a:fld>
             <a:endParaRPr lang="en-US"/>
           </a:p>
@@ -7313,7 +7313,7 @@
                   <a:srgbClr val="FFFFFF"/>
                 </a:solidFill>
               </a:rPr>
-              <a:t>$40 CPM</a:t>
+              <a:t>$XX CPM</a:t>
             </a:r>
           </a:p>
           <a:p>
@@ -7899,7 +7899,7 @@
                   <a:srgbClr val="FFFFFF"/>
                 </a:solidFill>
               </a:rPr>
-              <a:t>$35 CPM</a:t>
+              <a:t>$XX CPM</a:t>
             </a:r>
           </a:p>
           <a:p>
@@ -8082,7 +8082,7 @@
                   <a:srgbClr val="FFFFFF"/>
                 </a:solidFill>
               </a:rPr>
-              <a:t>$29 CPM</a:t>
+              <a:t>$XX CPM</a:t>
             </a:r>
           </a:p>
           <a:p>
@@ -10470,36 +10470,8 @@
 </file>
 
 <file path=customXml/item1.xml><?xml version="1.0" encoding="utf-8"?>
-<p:properties xmlns:p="http://schemas.microsoft.com/office/2006/metadata/properties" xmlns:xsi="http://www.w3.org/2001/XMLSchema-instance" xmlns:pc="http://schemas.microsoft.com/office/infopath/2007/PartnerControls">
-  <documentManagement>
-    <TaxCatchAll xmlns="a0547eee-aaa8-4b90-a1b8-3c540830c94d" xsi:nil="true"/>
-    <j54b65ba43ff43c48723fc8adc29d268 xmlns="a0547eee-aaa8-4b90-a1b8-3c540830c94d">
-      <Terms xmlns="http://schemas.microsoft.com/office/infopath/2007/PartnerControls"/>
-    </j54b65ba43ff43c48723fc8adc29d268>
-    <l420c45215364e2eb38c14ab041199ab xmlns="a0547eee-aaa8-4b90-a1b8-3c540830c94d">
-      <Terms xmlns="http://schemas.microsoft.com/office/infopath/2007/PartnerControls"/>
-    </l420c45215364e2eb38c14ab041199ab>
-    <la4ae81035174b1fba751a07ca4d086b xmlns="a0547eee-aaa8-4b90-a1b8-3c540830c94d">
-      <Terms xmlns="http://schemas.microsoft.com/office/infopath/2007/PartnerControls"/>
-    </la4ae81035174b1fba751a07ca4d086b>
-    <_dlc_DocIdPersistId xmlns="a0547eee-aaa8-4b90-a1b8-3c540830c94d" xsi:nil="true"/>
-    <SROwner xmlns="a0547eee-aaa8-4b90-a1b8-3c540830c94d">
-      <UserInfo>
-        <DisplayName/>
-        <AccountId xsi:nil="true"/>
-        <AccountType/>
-      </UserInfo>
-    </SROwner>
-    <SRRenewal xmlns="a0547eee-aaa8-4b90-a1b8-3c540830c94d" xsi:nil="true"/>
-    <j7c24873d3bf4df793fceec9ac332839 xmlns="a0547eee-aaa8-4b90-a1b8-3c540830c94d">
-      <Terms xmlns="http://schemas.microsoft.com/office/infopath/2007/PartnerControls"/>
-    </j7c24873d3bf4df793fceec9ac332839>
-    <SRThumbnail xmlns="a0547eee-aaa8-4b90-a1b8-3c540830c94d">
-      <Url xsi:nil="true"/>
-      <Description xsi:nil="true"/>
-    </SRThumbnail>
-  </documentManagement>
-</p:properties>
+<?mso-contentType ?>
+<FormTemplates xmlns="http://schemas.microsoft.com/sharepoint/v3/contenttype/forms"/>
 </file>
 
 <file path=customXml/item2.xml><?xml version="1.0" encoding="utf-8"?>
@@ -10774,8 +10746,36 @@
 </file>
 
 <file path=customXml/item3.xml><?xml version="1.0" encoding="utf-8"?>
-<?mso-contentType ?>
-<FormTemplates xmlns="http://schemas.microsoft.com/sharepoint/v3/contenttype/forms"/>
+<p:properties xmlns:p="http://schemas.microsoft.com/office/2006/metadata/properties" xmlns:xsi="http://www.w3.org/2001/XMLSchema-instance" xmlns:pc="http://schemas.microsoft.com/office/infopath/2007/PartnerControls">
+  <documentManagement>
+    <TaxCatchAll xmlns="a0547eee-aaa8-4b90-a1b8-3c540830c94d" xsi:nil="true"/>
+    <j54b65ba43ff43c48723fc8adc29d268 xmlns="a0547eee-aaa8-4b90-a1b8-3c540830c94d">
+      <Terms xmlns="http://schemas.microsoft.com/office/infopath/2007/PartnerControls"/>
+    </j54b65ba43ff43c48723fc8adc29d268>
+    <l420c45215364e2eb38c14ab041199ab xmlns="a0547eee-aaa8-4b90-a1b8-3c540830c94d">
+      <Terms xmlns="http://schemas.microsoft.com/office/infopath/2007/PartnerControls"/>
+    </l420c45215364e2eb38c14ab041199ab>
+    <la4ae81035174b1fba751a07ca4d086b xmlns="a0547eee-aaa8-4b90-a1b8-3c540830c94d">
+      <Terms xmlns="http://schemas.microsoft.com/office/infopath/2007/PartnerControls"/>
+    </la4ae81035174b1fba751a07ca4d086b>
+    <_dlc_DocIdPersistId xmlns="a0547eee-aaa8-4b90-a1b8-3c540830c94d" xsi:nil="true"/>
+    <SROwner xmlns="a0547eee-aaa8-4b90-a1b8-3c540830c94d">
+      <UserInfo>
+        <DisplayName/>
+        <AccountId xsi:nil="true"/>
+        <AccountType/>
+      </UserInfo>
+    </SROwner>
+    <SRRenewal xmlns="a0547eee-aaa8-4b90-a1b8-3c540830c94d" xsi:nil="true"/>
+    <j7c24873d3bf4df793fceec9ac332839 xmlns="a0547eee-aaa8-4b90-a1b8-3c540830c94d">
+      <Terms xmlns="http://schemas.microsoft.com/office/infopath/2007/PartnerControls"/>
+    </j7c24873d3bf4df793fceec9ac332839>
+    <SRThumbnail xmlns="a0547eee-aaa8-4b90-a1b8-3c540830c94d">
+      <Url xsi:nil="true"/>
+      <Description xsi:nil="true"/>
+    </SRThumbnail>
+  </documentManagement>
+</p:properties>
 </file>
 
 <file path=customXml/item4.xml><?xml version="1.0" encoding="utf-8"?>
@@ -10784,19 +10784,9 @@
 </file>
 
 <file path=customXml/itemProps1.xml><?xml version="1.0" encoding="utf-8"?>
-<ds:datastoreItem xmlns:ds="http://schemas.openxmlformats.org/officeDocument/2006/customXml" ds:itemID="{A4A687C3-2BAD-4AD7-9EA3-756AF9ACB115}">
+<ds:datastoreItem xmlns:ds="http://schemas.openxmlformats.org/officeDocument/2006/customXml" ds:itemID="{EC52D6D2-615C-42E8-A3C5-D765C3285355}">
   <ds:schemaRefs>
-    <ds:schemaRef ds:uri="http://schemas.microsoft.com/office/2006/metadata/properties"/>
-    <ds:schemaRef ds:uri="http://schemas.microsoft.com/office/infopath/2007/PartnerControls"/>
-    <ds:schemaRef ds:uri="http://www.w3.org/XML/1998/namespace"/>
-    <ds:schemaRef ds:uri="http://schemas.microsoft.com/office/2006/documentManagement/types"/>
-    <ds:schemaRef ds:uri="http://purl.org/dc/elements/1.1/"/>
-    <ds:schemaRef ds:uri="http://purl.org/dc/terms/"/>
-    <ds:schemaRef ds:uri="0212352b-2682-46bb-beb5-9da4ea9226e1"/>
-    <ds:schemaRef ds:uri="7a70ef4c-5183-4fb2-bf69-1cc1bbd63d67"/>
-    <ds:schemaRef ds:uri="http://schemas.openxmlformats.org/package/2006/metadata/core-properties"/>
-    <ds:schemaRef ds:uri="http://purl.org/dc/dcmitype/"/>
-    <ds:schemaRef ds:uri="a0547eee-aaa8-4b90-a1b8-3c540830c94d"/>
+    <ds:schemaRef ds:uri="http://schemas.microsoft.com/sharepoint/v3/contenttype/forms"/>
   </ds:schemaRefs>
 </ds:datastoreItem>
 </file>
@@ -10821,9 +10811,19 @@
 </file>
 
 <file path=customXml/itemProps3.xml><?xml version="1.0" encoding="utf-8"?>
-<ds:datastoreItem xmlns:ds="http://schemas.openxmlformats.org/officeDocument/2006/customXml" ds:itemID="{EC52D6D2-615C-42E8-A3C5-D765C3285355}">
+<ds:datastoreItem xmlns:ds="http://schemas.openxmlformats.org/officeDocument/2006/customXml" ds:itemID="{A4A687C3-2BAD-4AD7-9EA3-756AF9ACB115}">
   <ds:schemaRefs>
-    <ds:schemaRef ds:uri="http://schemas.microsoft.com/sharepoint/v3/contenttype/forms"/>
+    <ds:schemaRef ds:uri="http://schemas.microsoft.com/office/2006/metadata/properties"/>
+    <ds:schemaRef ds:uri="http://schemas.microsoft.com/office/infopath/2007/PartnerControls"/>
+    <ds:schemaRef ds:uri="http://www.w3.org/XML/1998/namespace"/>
+    <ds:schemaRef ds:uri="http://schemas.microsoft.com/office/2006/documentManagement/types"/>
+    <ds:schemaRef ds:uri="http://purl.org/dc/elements/1.1/"/>
+    <ds:schemaRef ds:uri="http://purl.org/dc/terms/"/>
+    <ds:schemaRef ds:uri="0212352b-2682-46bb-beb5-9da4ea9226e1"/>
+    <ds:schemaRef ds:uri="7a70ef4c-5183-4fb2-bf69-1cc1bbd63d67"/>
+    <ds:schemaRef ds:uri="http://schemas.openxmlformats.org/package/2006/metadata/core-properties"/>
+    <ds:schemaRef ds:uri="http://purl.org/dc/dcmitype/"/>
+    <ds:schemaRef ds:uri="a0547eee-aaa8-4b90-a1b8-3c540830c94d"/>
   </ds:schemaRefs>
 </ds:datastoreItem>
 </file>

</xml_diff>